<commit_message>
Verifying Permissions in Blade Templates
</commit_message>
<xml_diff>
--- a/.lessons/29 Fundamental Authorization ( Yalnız öz yazısını silə bilər A sayılır )/3 Verifying Permissions in Blade Templates/1.pptx
+++ b/.lessons/29 Fundamental Authorization ( Yalnız öz yazısını silə bilər A sayılır )/3 Verifying Permissions in Blade Templates/1.pptx
@@ -7,7 +7,12 @@
   <p:sldIdLst>
     <p:sldId id="402" r:id="rId2"/>
     <p:sldId id="403" r:id="rId3"/>
-    <p:sldId id="400" r:id="rId4"/>
+    <p:sldId id="404" r:id="rId4"/>
+    <p:sldId id="405" r:id="rId5"/>
+    <p:sldId id="400" r:id="rId6"/>
+    <p:sldId id="406" r:id="rId7"/>
+    <p:sldId id="407" r:id="rId8"/>
+    <p:sldId id="408" r:id="rId9"/>
   </p:sldIdLst>
   <p:sldSz cx="12192000" cy="6858000"/>
   <p:notesSz cx="6858000" cy="9144000"/>
@@ -261,7 +266,7 @@
           <a:p>
             <a:fld id="{3E102D2E-813C-461C-9963-687A650C48C0}" type="datetimeFigureOut">
               <a:rPr lang="en-US" smtClean="0"/>
-              <a:t>5/23/2025</a:t>
+              <a:t>6/2/2025</a:t>
             </a:fld>
             <a:endParaRPr lang="en-US"/>
           </a:p>
@@ -459,7 +464,7 @@
           <a:p>
             <a:fld id="{3E102D2E-813C-461C-9963-687A650C48C0}" type="datetimeFigureOut">
               <a:rPr lang="en-US" smtClean="0"/>
-              <a:t>5/23/2025</a:t>
+              <a:t>6/2/2025</a:t>
             </a:fld>
             <a:endParaRPr lang="en-US"/>
           </a:p>
@@ -667,7 +672,7 @@
           <a:p>
             <a:fld id="{3E102D2E-813C-461C-9963-687A650C48C0}" type="datetimeFigureOut">
               <a:rPr lang="en-US" smtClean="0"/>
-              <a:t>5/23/2025</a:t>
+              <a:t>6/2/2025</a:t>
             </a:fld>
             <a:endParaRPr lang="en-US"/>
           </a:p>
@@ -865,7 +870,7 @@
           <a:p>
             <a:fld id="{3E102D2E-813C-461C-9963-687A650C48C0}" type="datetimeFigureOut">
               <a:rPr lang="en-US" smtClean="0"/>
-              <a:t>5/23/2025</a:t>
+              <a:t>6/2/2025</a:t>
             </a:fld>
             <a:endParaRPr lang="en-US"/>
           </a:p>
@@ -1140,7 +1145,7 @@
           <a:p>
             <a:fld id="{3E102D2E-813C-461C-9963-687A650C48C0}" type="datetimeFigureOut">
               <a:rPr lang="en-US" smtClean="0"/>
-              <a:t>5/23/2025</a:t>
+              <a:t>6/2/2025</a:t>
             </a:fld>
             <a:endParaRPr lang="en-US"/>
           </a:p>
@@ -1405,7 +1410,7 @@
           <a:p>
             <a:fld id="{3E102D2E-813C-461C-9963-687A650C48C0}" type="datetimeFigureOut">
               <a:rPr lang="en-US" smtClean="0"/>
-              <a:t>5/23/2025</a:t>
+              <a:t>6/2/2025</a:t>
             </a:fld>
             <a:endParaRPr lang="en-US"/>
           </a:p>
@@ -1817,7 +1822,7 @@
           <a:p>
             <a:fld id="{3E102D2E-813C-461C-9963-687A650C48C0}" type="datetimeFigureOut">
               <a:rPr lang="en-US" smtClean="0"/>
-              <a:t>5/23/2025</a:t>
+              <a:t>6/2/2025</a:t>
             </a:fld>
             <a:endParaRPr lang="en-US"/>
           </a:p>
@@ -1958,7 +1963,7 @@
           <a:p>
             <a:fld id="{3E102D2E-813C-461C-9963-687A650C48C0}" type="datetimeFigureOut">
               <a:rPr lang="en-US" smtClean="0"/>
-              <a:t>5/23/2025</a:t>
+              <a:t>6/2/2025</a:t>
             </a:fld>
             <a:endParaRPr lang="en-US"/>
           </a:p>
@@ -2071,7 +2076,7 @@
           <a:p>
             <a:fld id="{3E102D2E-813C-461C-9963-687A650C48C0}" type="datetimeFigureOut">
               <a:rPr lang="en-US" smtClean="0"/>
-              <a:t>5/23/2025</a:t>
+              <a:t>6/2/2025</a:t>
             </a:fld>
             <a:endParaRPr lang="en-US"/>
           </a:p>
@@ -2382,7 +2387,7 @@
           <a:p>
             <a:fld id="{3E102D2E-813C-461C-9963-687A650C48C0}" type="datetimeFigureOut">
               <a:rPr lang="en-US" smtClean="0"/>
-              <a:t>5/23/2025</a:t>
+              <a:t>6/2/2025</a:t>
             </a:fld>
             <a:endParaRPr lang="en-US"/>
           </a:p>
@@ -2670,7 +2675,7 @@
           <a:p>
             <a:fld id="{3E102D2E-813C-461C-9963-687A650C48C0}" type="datetimeFigureOut">
               <a:rPr lang="en-US" smtClean="0"/>
-              <a:t>5/23/2025</a:t>
+              <a:t>6/2/2025</a:t>
             </a:fld>
             <a:endParaRPr lang="en-US"/>
           </a:p>
@@ -2911,7 +2916,7 @@
           <a:p>
             <a:fld id="{3E102D2E-813C-461C-9963-687A650C48C0}" type="datetimeFigureOut">
               <a:rPr lang="en-US" smtClean="0"/>
-              <a:t>5/23/2025</a:t>
+              <a:t>6/2/2025</a:t>
             </a:fld>
             <a:endParaRPr lang="en-US"/>
           </a:p>
@@ -3349,7 +3354,7 @@
         <p:spPr>
           <a:xfrm>
             <a:off x="217714" y="255046"/>
-            <a:ext cx="11756571" cy="355354"/>
+            <a:ext cx="11756571" cy="1255600"/>
           </a:xfrm>
           <a:prstGeom prst="rect">
             <a:avLst/>
@@ -3368,6 +3373,19 @@
               </a:lnSpc>
               <a:buNone/>
             </a:pPr>
+            <a:r>
+              <a:rPr kumimoji="0" lang="en-US" altLang="en-US" sz="1300" b="1" i="0" u="none" strike="noStrike" cap="none" normalizeH="0" baseline="0">
+                <a:ln>
+                  <a:noFill/>
+                </a:ln>
+                <a:solidFill>
+                  <a:srgbClr val="FF0000"/>
+                </a:solidFill>
+                <a:effectLst/>
+                <a:latin typeface="Arial" panose="020B0604020202020204" pitchFamily="34" charset="0"/>
+              </a:rPr>
+              <a:t>Alternativ</a:t>
+            </a:r>
             <a:r>
               <a:rPr kumimoji="0" lang="en-US" altLang="en-US" sz="1300" b="0" i="0" u="none" strike="noStrike" cap="none" normalizeH="0" baseline="0">
                 <a:ln>
@@ -3379,11 +3397,117 @@
                 <a:effectLst/>
                 <a:latin typeface="Arial" panose="020B0604020202020204" pitchFamily="34" charset="0"/>
               </a:rPr>
-              <a:t>.</a:t>
-            </a:r>
-          </a:p>
-        </p:txBody>
-      </p:sp>
+              <a:t> – </a:t>
+            </a:r>
+            <a:r>
+              <a:rPr kumimoji="0" lang="en-US" altLang="en-US" sz="1300" b="1" i="0" u="none" strike="noStrike" cap="none" normalizeH="0" baseline="0">
+                <a:ln>
+                  <a:noFill/>
+                </a:ln>
+                <a:solidFill>
+                  <a:srgbClr val="FF0000"/>
+                </a:solidFill>
+                <a:effectLst/>
+                <a:latin typeface="Arial" panose="020B0604020202020204" pitchFamily="34" charset="0"/>
+              </a:rPr>
+              <a:t>İcazəni Blade içində yoxlamaq</a:t>
+            </a:r>
+          </a:p>
+          <a:p>
+            <a:pPr>
+              <a:lnSpc>
+                <a:spcPct val="150000"/>
+              </a:lnSpc>
+              <a:buNone/>
+            </a:pPr>
+            <a:endParaRPr lang="en-US" altLang="en-US" sz="1300">
+              <a:latin typeface="Arial" panose="020B0604020202020204" pitchFamily="34" charset="0"/>
+            </a:endParaRPr>
+          </a:p>
+          <a:p>
+            <a:pPr>
+              <a:lnSpc>
+                <a:spcPct val="150000"/>
+              </a:lnSpc>
+              <a:buNone/>
+            </a:pPr>
+            <a:endParaRPr kumimoji="0" lang="en-US" altLang="en-US" sz="1300" b="0" i="0" u="none" strike="noStrike" cap="none" normalizeH="0" baseline="0">
+              <a:ln>
+                <a:noFill/>
+              </a:ln>
+              <a:solidFill>
+                <a:schemeClr val="tx1"/>
+              </a:solidFill>
+              <a:effectLst/>
+              <a:latin typeface="Arial" panose="020B0604020202020204" pitchFamily="34" charset="0"/>
+            </a:endParaRPr>
+          </a:p>
+          <a:p>
+            <a:pPr>
+              <a:lnSpc>
+                <a:spcPct val="150000"/>
+              </a:lnSpc>
+              <a:buNone/>
+            </a:pPr>
+            <a:r>
+              <a:rPr kumimoji="0" lang="en-US" altLang="en-US" sz="1300" b="1" i="0" u="none" strike="noStrike" cap="none" normalizeH="0" baseline="0">
+                <a:ln>
+                  <a:noFill/>
+                </a:ln>
+                <a:solidFill>
+                  <a:schemeClr val="tx1"/>
+                </a:solidFill>
+                <a:effectLst/>
+                <a:latin typeface="Arial" panose="020B0604020202020204" pitchFamily="34" charset="0"/>
+              </a:rPr>
+              <a:t>Blade</a:t>
+            </a:r>
+            <a:r>
+              <a:rPr kumimoji="0" lang="en-US" altLang="en-US" sz="1300" b="0" i="0" u="none" strike="noStrike" cap="none" normalizeH="0" baseline="0">
+                <a:ln>
+                  <a:noFill/>
+                </a:ln>
+                <a:solidFill>
+                  <a:schemeClr val="tx1"/>
+                </a:solidFill>
+                <a:effectLst/>
+                <a:latin typeface="Arial" panose="020B0604020202020204" pitchFamily="34" charset="0"/>
+              </a:rPr>
+              <a:t> faylınızda belə də yoxlaya bilərsiniz:   bu, görünüş səviyyəsində icazə yoxlamasıdır – icazəsi olmayanlara link belə göstərilmir.</a:t>
+            </a:r>
+          </a:p>
+        </p:txBody>
+      </p:sp>
+      <p:pic>
+        <p:nvPicPr>
+          <p:cNvPr id="4" name="Picture 3">
+            <a:extLst>
+              <a:ext uri="{FF2B5EF4-FFF2-40B4-BE49-F238E27FC236}">
+                <a16:creationId xmlns:a16="http://schemas.microsoft.com/office/drawing/2014/main" id="{06B2A3B8-2F2A-2B52-F5D5-928D89F66172}"/>
+              </a:ext>
+            </a:extLst>
+          </p:cNvPr>
+          <p:cNvPicPr>
+            <a:picLocks noChangeAspect="1"/>
+          </p:cNvPicPr>
+          <p:nvPr/>
+        </p:nvPicPr>
+        <p:blipFill>
+          <a:blip r:embed="rId2"/>
+          <a:stretch>
+            <a:fillRect/>
+          </a:stretch>
+        </p:blipFill>
+        <p:spPr>
+          <a:xfrm>
+            <a:off x="0" y="1700430"/>
+            <a:ext cx="4620270" cy="1000265"/>
+          </a:xfrm>
+          <a:prstGeom prst="rect">
+            <a:avLst/>
+          </a:prstGeom>
+        </p:spPr>
+      </p:pic>
     </p:spTree>
     <p:extLst>
       <p:ext uri="{BB962C8B-B14F-4D97-AF65-F5344CB8AC3E}">
@@ -3434,8 +3558,8 @@
         </p:nvSpPr>
         <p:spPr>
           <a:xfrm>
-            <a:off x="217714" y="255046"/>
-            <a:ext cx="11756571" cy="355354"/>
+            <a:off x="217715" y="255046"/>
+            <a:ext cx="3486068" cy="355354"/>
           </a:xfrm>
           <a:prstGeom prst="rect">
             <a:avLst/>
@@ -3455,7 +3579,7 @@
               <a:buNone/>
             </a:pPr>
             <a:r>
-              <a:rPr kumimoji="0" lang="en-US" altLang="en-US" sz="1300" b="0" i="0" u="none" strike="noStrike" cap="none" normalizeH="0" baseline="0">
+              <a:rPr kumimoji="0" lang="az-Latn-AZ" altLang="en-US" sz="1300" b="0" i="0" u="none" strike="noStrike" cap="none" normalizeH="0" baseline="0">
                 <a:ln>
                   <a:noFill/>
                 </a:ln>
@@ -3465,11 +3589,51 @@
                 <a:effectLst/>
                 <a:latin typeface="Arial" panose="020B0604020202020204" pitchFamily="34" charset="0"/>
               </a:rPr>
-              <a:t>.</a:t>
-            </a:r>
-          </a:p>
-        </p:txBody>
-      </p:sp>
+              <a:t>Şəkildəki kimi şablonda qeyd edirik. </a:t>
+            </a:r>
+            <a:endParaRPr kumimoji="0" lang="en-US" altLang="en-US" sz="1300" b="0" i="0" u="none" strike="noStrike" cap="none" normalizeH="0" baseline="0">
+              <a:ln>
+                <a:noFill/>
+              </a:ln>
+              <a:solidFill>
+                <a:schemeClr val="tx1"/>
+              </a:solidFill>
+              <a:effectLst/>
+              <a:latin typeface="Arial" panose="020B0604020202020204" pitchFamily="34" charset="0"/>
+            </a:endParaRPr>
+          </a:p>
+        </p:txBody>
+      </p:sp>
+      <p:pic>
+        <p:nvPicPr>
+          <p:cNvPr id="4" name="Picture 3">
+            <a:extLst>
+              <a:ext uri="{FF2B5EF4-FFF2-40B4-BE49-F238E27FC236}">
+                <a16:creationId xmlns:a16="http://schemas.microsoft.com/office/drawing/2014/main" id="{DF428858-A02E-3997-813A-5E52760A990C}"/>
+              </a:ext>
+            </a:extLst>
+          </p:cNvPr>
+          <p:cNvPicPr>
+            <a:picLocks noChangeAspect="1"/>
+          </p:cNvPicPr>
+          <p:nvPr/>
+        </p:nvPicPr>
+        <p:blipFill>
+          <a:blip r:embed="rId2"/>
+          <a:stretch>
+            <a:fillRect/>
+          </a:stretch>
+        </p:blipFill>
+        <p:spPr>
+          <a:xfrm>
+            <a:off x="4066836" y="0"/>
+            <a:ext cx="8125164" cy="6858000"/>
+          </a:xfrm>
+          <a:prstGeom prst="rect">
+            <a:avLst/>
+          </a:prstGeom>
+        </p:spPr>
+      </p:pic>
     </p:spTree>
     <p:extLst>
       <p:ext uri="{BB962C8B-B14F-4D97-AF65-F5344CB8AC3E}">
@@ -3484,6 +3648,269 @@
 </file>
 
 <file path=ppt/slides/slide3.xml><?xml version="1.0" encoding="utf-8"?>
+<p:sld xmlns:a="http://schemas.openxmlformats.org/drawingml/2006/main" xmlns:r="http://schemas.openxmlformats.org/officeDocument/2006/relationships" xmlns:p="http://schemas.openxmlformats.org/presentationml/2006/main">
+  <p:cSld>
+    <p:spTree>
+      <p:nvGrpSpPr>
+        <p:cNvPr id="1" name="">
+          <a:extLst>
+            <a:ext uri="{FF2B5EF4-FFF2-40B4-BE49-F238E27FC236}">
+              <a16:creationId xmlns:a16="http://schemas.microsoft.com/office/drawing/2014/main" id="{A62E4D83-581C-73EF-E0E5-5818A7D47446}"/>
+            </a:ext>
+          </a:extLst>
+        </p:cNvPr>
+        <p:cNvGrpSpPr/>
+        <p:nvPr/>
+      </p:nvGrpSpPr>
+      <p:grpSpPr>
+        <a:xfrm>
+          <a:off x="0" y="0"/>
+          <a:ext cx="0" cy="0"/>
+          <a:chOff x="0" y="0"/>
+          <a:chExt cx="0" cy="0"/>
+        </a:xfrm>
+      </p:grpSpPr>
+      <p:sp>
+        <p:nvSpPr>
+          <p:cNvPr id="3" name="TextBox 2">
+            <a:extLst>
+              <a:ext uri="{FF2B5EF4-FFF2-40B4-BE49-F238E27FC236}">
+                <a16:creationId xmlns:a16="http://schemas.microsoft.com/office/drawing/2014/main" id="{9C7414CE-E6FA-B100-7DCF-251FFB3EE7B5}"/>
+              </a:ext>
+            </a:extLst>
+          </p:cNvPr>
+          <p:cNvSpPr txBox="1"/>
+          <p:nvPr/>
+        </p:nvSpPr>
+        <p:spPr>
+          <a:xfrm>
+            <a:off x="217714" y="255046"/>
+            <a:ext cx="11756571" cy="355354"/>
+          </a:xfrm>
+          <a:prstGeom prst="rect">
+            <a:avLst/>
+          </a:prstGeom>
+          <a:noFill/>
+        </p:spPr>
+        <p:txBody>
+          <a:bodyPr wrap="square">
+            <a:spAutoFit/>
+          </a:bodyPr>
+          <a:lstStyle/>
+          <a:p>
+            <a:pPr>
+              <a:lnSpc>
+                <a:spcPct val="150000"/>
+              </a:lnSpc>
+              <a:buNone/>
+            </a:pPr>
+            <a:r>
+              <a:rPr lang="az-Latn-AZ" altLang="en-US" sz="1300">
+                <a:latin typeface="Arial" panose="020B0604020202020204" pitchFamily="34" charset="0"/>
+              </a:rPr>
+              <a:t>Əgər `is_admin` sıfır ( 0 ) olarsa onda elementlər görünməyəcək. </a:t>
+            </a:r>
+            <a:endParaRPr kumimoji="0" lang="en-US" altLang="en-US" sz="1300" b="0" i="0" u="none" strike="noStrike" cap="none" normalizeH="0" baseline="0">
+              <a:ln>
+                <a:noFill/>
+              </a:ln>
+              <a:solidFill>
+                <a:schemeClr val="tx1"/>
+              </a:solidFill>
+              <a:effectLst/>
+              <a:latin typeface="Arial" panose="020B0604020202020204" pitchFamily="34" charset="0"/>
+            </a:endParaRPr>
+          </a:p>
+        </p:txBody>
+      </p:sp>
+      <p:pic>
+        <p:nvPicPr>
+          <p:cNvPr id="4" name="Picture 3">
+            <a:extLst>
+              <a:ext uri="{FF2B5EF4-FFF2-40B4-BE49-F238E27FC236}">
+                <a16:creationId xmlns:a16="http://schemas.microsoft.com/office/drawing/2014/main" id="{2D666BF3-9B21-3CCC-DCD7-CC5291E4ED78}"/>
+              </a:ext>
+            </a:extLst>
+          </p:cNvPr>
+          <p:cNvPicPr>
+            <a:picLocks noChangeAspect="1"/>
+          </p:cNvPicPr>
+          <p:nvPr/>
+        </p:nvPicPr>
+        <p:blipFill>
+          <a:blip r:embed="rId2"/>
+          <a:stretch>
+            <a:fillRect/>
+          </a:stretch>
+        </p:blipFill>
+        <p:spPr>
+          <a:xfrm>
+            <a:off x="0" y="2375413"/>
+            <a:ext cx="12192000" cy="2107173"/>
+          </a:xfrm>
+          <a:prstGeom prst="rect">
+            <a:avLst/>
+          </a:prstGeom>
+          <a:ln w="38100" cap="sq">
+            <a:solidFill>
+              <a:srgbClr val="000000"/>
+            </a:solidFill>
+            <a:prstDash val="solid"/>
+            <a:miter lim="800000"/>
+          </a:ln>
+          <a:effectLst>
+            <a:outerShdw blurRad="50800" dist="38100" dir="2700000" algn="tl" rotWithShape="0">
+              <a:srgbClr val="000000">
+                <a:alpha val="43000"/>
+              </a:srgbClr>
+            </a:outerShdw>
+          </a:effectLst>
+        </p:spPr>
+      </p:pic>
+    </p:spTree>
+    <p:extLst>
+      <p:ext uri="{BB962C8B-B14F-4D97-AF65-F5344CB8AC3E}">
+        <p14:creationId xmlns:p14="http://schemas.microsoft.com/office/powerpoint/2010/main" val="1723929597"/>
+      </p:ext>
+    </p:extLst>
+  </p:cSld>
+  <p:clrMapOvr>
+    <a:masterClrMapping/>
+  </p:clrMapOvr>
+</p:sld>
+</file>
+
+<file path=ppt/slides/slide4.xml><?xml version="1.0" encoding="utf-8"?>
+<p:sld xmlns:a="http://schemas.openxmlformats.org/drawingml/2006/main" xmlns:r="http://schemas.openxmlformats.org/officeDocument/2006/relationships" xmlns:p="http://schemas.openxmlformats.org/presentationml/2006/main">
+  <p:cSld>
+    <p:spTree>
+      <p:nvGrpSpPr>
+        <p:cNvPr id="1" name="">
+          <a:extLst>
+            <a:ext uri="{FF2B5EF4-FFF2-40B4-BE49-F238E27FC236}">
+              <a16:creationId xmlns:a16="http://schemas.microsoft.com/office/drawing/2014/main" id="{1A73033B-8620-CE2C-B6F1-68D055523360}"/>
+            </a:ext>
+          </a:extLst>
+        </p:cNvPr>
+        <p:cNvGrpSpPr/>
+        <p:nvPr/>
+      </p:nvGrpSpPr>
+      <p:grpSpPr>
+        <a:xfrm>
+          <a:off x="0" y="0"/>
+          <a:ext cx="0" cy="0"/>
+          <a:chOff x="0" y="0"/>
+          <a:chExt cx="0" cy="0"/>
+        </a:xfrm>
+      </p:grpSpPr>
+      <p:sp>
+        <p:nvSpPr>
+          <p:cNvPr id="3" name="TextBox 2">
+            <a:extLst>
+              <a:ext uri="{FF2B5EF4-FFF2-40B4-BE49-F238E27FC236}">
+                <a16:creationId xmlns:a16="http://schemas.microsoft.com/office/drawing/2014/main" id="{B6F1420D-2FA6-F98E-0606-2D910F32729F}"/>
+              </a:ext>
+            </a:extLst>
+          </p:cNvPr>
+          <p:cNvSpPr txBox="1"/>
+          <p:nvPr/>
+        </p:nvSpPr>
+        <p:spPr>
+          <a:xfrm>
+            <a:off x="217714" y="255046"/>
+            <a:ext cx="11756571" cy="355354"/>
+          </a:xfrm>
+          <a:prstGeom prst="rect">
+            <a:avLst/>
+          </a:prstGeom>
+          <a:noFill/>
+        </p:spPr>
+        <p:txBody>
+          <a:bodyPr wrap="square">
+            <a:spAutoFit/>
+          </a:bodyPr>
+          <a:lstStyle/>
+          <a:p>
+            <a:pPr>
+              <a:lnSpc>
+                <a:spcPct val="150000"/>
+              </a:lnSpc>
+              <a:buNone/>
+            </a:pPr>
+            <a:r>
+              <a:rPr kumimoji="0" lang="en-US" altLang="en-US" sz="1300" b="0" i="0" u="none" strike="noStrike" cap="none" normalizeH="0" baseline="0">
+                <a:ln>
+                  <a:noFill/>
+                </a:ln>
+                <a:solidFill>
+                  <a:schemeClr val="tx1"/>
+                </a:solidFill>
+                <a:effectLst/>
+                <a:latin typeface="Arial" panose="020B0604020202020204" pitchFamily="34" charset="0"/>
+              </a:rPr>
+              <a:t>.</a:t>
+            </a:r>
+          </a:p>
+        </p:txBody>
+      </p:sp>
+      <p:pic>
+        <p:nvPicPr>
+          <p:cNvPr id="4" name="Picture 3">
+            <a:extLst>
+              <a:ext uri="{FF2B5EF4-FFF2-40B4-BE49-F238E27FC236}">
+                <a16:creationId xmlns:a16="http://schemas.microsoft.com/office/drawing/2014/main" id="{8D67849E-E4F5-A04B-325E-1D1EF50F9B2B}"/>
+              </a:ext>
+            </a:extLst>
+          </p:cNvPr>
+          <p:cNvPicPr>
+            <a:picLocks noChangeAspect="1"/>
+          </p:cNvPicPr>
+          <p:nvPr/>
+        </p:nvPicPr>
+        <p:blipFill>
+          <a:blip r:embed="rId2"/>
+          <a:stretch>
+            <a:fillRect/>
+          </a:stretch>
+        </p:blipFill>
+        <p:spPr>
+          <a:xfrm>
+            <a:off x="0" y="570805"/>
+            <a:ext cx="12192000" cy="6287195"/>
+          </a:xfrm>
+          <a:prstGeom prst="rect">
+            <a:avLst/>
+          </a:prstGeom>
+          <a:ln w="38100" cap="sq">
+            <a:solidFill>
+              <a:srgbClr val="000000"/>
+            </a:solidFill>
+            <a:prstDash val="solid"/>
+            <a:miter lim="800000"/>
+          </a:ln>
+          <a:effectLst>
+            <a:outerShdw blurRad="50800" dist="38100" dir="2700000" algn="tl" rotWithShape="0">
+              <a:srgbClr val="000000">
+                <a:alpha val="43000"/>
+              </a:srgbClr>
+            </a:outerShdw>
+          </a:effectLst>
+        </p:spPr>
+      </p:pic>
+    </p:spTree>
+    <p:extLst>
+      <p:ext uri="{BB962C8B-B14F-4D97-AF65-F5344CB8AC3E}">
+        <p14:creationId xmlns:p14="http://schemas.microsoft.com/office/powerpoint/2010/main" val="1142558125"/>
+      </p:ext>
+    </p:extLst>
+  </p:cSld>
+  <p:clrMapOvr>
+    <a:masterClrMapping/>
+  </p:clrMapOvr>
+</p:sld>
+</file>
+
+<file path=ppt/slides/slide5.xml><?xml version="1.0" encoding="utf-8"?>
 <p:sld xmlns:a="http://schemas.openxmlformats.org/drawingml/2006/main" xmlns:r="http://schemas.openxmlformats.org/officeDocument/2006/relationships" xmlns:p="http://schemas.openxmlformats.org/presentationml/2006/main">
   <p:cSld>
     <p:spTree>
@@ -3560,6 +3987,264 @@
     <p:extLst>
       <p:ext uri="{BB962C8B-B14F-4D97-AF65-F5344CB8AC3E}">
         <p14:creationId xmlns:p14="http://schemas.microsoft.com/office/powerpoint/2010/main" val="3095838342"/>
+      </p:ext>
+    </p:extLst>
+  </p:cSld>
+  <p:clrMapOvr>
+    <a:masterClrMapping/>
+  </p:clrMapOvr>
+</p:sld>
+</file>
+
+<file path=ppt/slides/slide6.xml><?xml version="1.0" encoding="utf-8"?>
+<p:sld xmlns:a="http://schemas.openxmlformats.org/drawingml/2006/main" xmlns:r="http://schemas.openxmlformats.org/officeDocument/2006/relationships" xmlns:p="http://schemas.openxmlformats.org/presentationml/2006/main">
+  <p:cSld>
+    <p:spTree>
+      <p:nvGrpSpPr>
+        <p:cNvPr id="1" name="">
+          <a:extLst>
+            <a:ext uri="{FF2B5EF4-FFF2-40B4-BE49-F238E27FC236}">
+              <a16:creationId xmlns:a16="http://schemas.microsoft.com/office/drawing/2014/main" id="{885DE4F0-6482-D074-24CE-E356D4CAAF6A}"/>
+            </a:ext>
+          </a:extLst>
+        </p:cNvPr>
+        <p:cNvGrpSpPr/>
+        <p:nvPr/>
+      </p:nvGrpSpPr>
+      <p:grpSpPr>
+        <a:xfrm>
+          <a:off x="0" y="0"/>
+          <a:ext cx="0" cy="0"/>
+          <a:chOff x="0" y="0"/>
+          <a:chExt cx="0" cy="0"/>
+        </a:xfrm>
+      </p:grpSpPr>
+      <p:sp>
+        <p:nvSpPr>
+          <p:cNvPr id="3" name="TextBox 2">
+            <a:extLst>
+              <a:ext uri="{FF2B5EF4-FFF2-40B4-BE49-F238E27FC236}">
+                <a16:creationId xmlns:a16="http://schemas.microsoft.com/office/drawing/2014/main" id="{51DBC34D-403F-3448-3BB3-7E35DC0E644D}"/>
+              </a:ext>
+            </a:extLst>
+          </p:cNvPr>
+          <p:cNvSpPr txBox="1"/>
+          <p:nvPr/>
+        </p:nvSpPr>
+        <p:spPr>
+          <a:xfrm>
+            <a:off x="217714" y="255046"/>
+            <a:ext cx="11756571" cy="355354"/>
+          </a:xfrm>
+          <a:prstGeom prst="rect">
+            <a:avLst/>
+          </a:prstGeom>
+          <a:noFill/>
+        </p:spPr>
+        <p:txBody>
+          <a:bodyPr wrap="square">
+            <a:spAutoFit/>
+          </a:bodyPr>
+          <a:lstStyle/>
+          <a:p>
+            <a:pPr>
+              <a:lnSpc>
+                <a:spcPct val="150000"/>
+              </a:lnSpc>
+              <a:buNone/>
+            </a:pPr>
+            <a:r>
+              <a:rPr kumimoji="0" lang="en-US" altLang="en-US" sz="1300" b="0" i="0" u="none" strike="noStrike" cap="none" normalizeH="0" baseline="0">
+                <a:ln>
+                  <a:noFill/>
+                </a:ln>
+                <a:solidFill>
+                  <a:schemeClr val="tx1"/>
+                </a:solidFill>
+                <a:effectLst/>
+                <a:latin typeface="Arial" panose="020B0604020202020204" pitchFamily="34" charset="0"/>
+              </a:rPr>
+              <a:t>.</a:t>
+            </a:r>
+          </a:p>
+        </p:txBody>
+      </p:sp>
+    </p:spTree>
+    <p:extLst>
+      <p:ext uri="{BB962C8B-B14F-4D97-AF65-F5344CB8AC3E}">
+        <p14:creationId xmlns:p14="http://schemas.microsoft.com/office/powerpoint/2010/main" val="3303797549"/>
+      </p:ext>
+    </p:extLst>
+  </p:cSld>
+  <p:clrMapOvr>
+    <a:masterClrMapping/>
+  </p:clrMapOvr>
+</p:sld>
+</file>
+
+<file path=ppt/slides/slide7.xml><?xml version="1.0" encoding="utf-8"?>
+<p:sld xmlns:a="http://schemas.openxmlformats.org/drawingml/2006/main" xmlns:r="http://schemas.openxmlformats.org/officeDocument/2006/relationships" xmlns:p="http://schemas.openxmlformats.org/presentationml/2006/main">
+  <p:cSld>
+    <p:spTree>
+      <p:nvGrpSpPr>
+        <p:cNvPr id="1" name="">
+          <a:extLst>
+            <a:ext uri="{FF2B5EF4-FFF2-40B4-BE49-F238E27FC236}">
+              <a16:creationId xmlns:a16="http://schemas.microsoft.com/office/drawing/2014/main" id="{7C8A9A63-9DB0-DDC0-0539-2C51E0AAAF04}"/>
+            </a:ext>
+          </a:extLst>
+        </p:cNvPr>
+        <p:cNvGrpSpPr/>
+        <p:nvPr/>
+      </p:nvGrpSpPr>
+      <p:grpSpPr>
+        <a:xfrm>
+          <a:off x="0" y="0"/>
+          <a:ext cx="0" cy="0"/>
+          <a:chOff x="0" y="0"/>
+          <a:chExt cx="0" cy="0"/>
+        </a:xfrm>
+      </p:grpSpPr>
+      <p:sp>
+        <p:nvSpPr>
+          <p:cNvPr id="3" name="TextBox 2">
+            <a:extLst>
+              <a:ext uri="{FF2B5EF4-FFF2-40B4-BE49-F238E27FC236}">
+                <a16:creationId xmlns:a16="http://schemas.microsoft.com/office/drawing/2014/main" id="{C8F2405F-6EB8-516D-CFCA-64F8ACA50DDC}"/>
+              </a:ext>
+            </a:extLst>
+          </p:cNvPr>
+          <p:cNvSpPr txBox="1"/>
+          <p:nvPr/>
+        </p:nvSpPr>
+        <p:spPr>
+          <a:xfrm>
+            <a:off x="217714" y="255046"/>
+            <a:ext cx="11756571" cy="355354"/>
+          </a:xfrm>
+          <a:prstGeom prst="rect">
+            <a:avLst/>
+          </a:prstGeom>
+          <a:noFill/>
+        </p:spPr>
+        <p:txBody>
+          <a:bodyPr wrap="square">
+            <a:spAutoFit/>
+          </a:bodyPr>
+          <a:lstStyle/>
+          <a:p>
+            <a:pPr>
+              <a:lnSpc>
+                <a:spcPct val="150000"/>
+              </a:lnSpc>
+              <a:buNone/>
+            </a:pPr>
+            <a:r>
+              <a:rPr kumimoji="0" lang="en-US" altLang="en-US" sz="1300" b="0" i="0" u="none" strike="noStrike" cap="none" normalizeH="0" baseline="0">
+                <a:ln>
+                  <a:noFill/>
+                </a:ln>
+                <a:solidFill>
+                  <a:schemeClr val="tx1"/>
+                </a:solidFill>
+                <a:effectLst/>
+                <a:latin typeface="Arial" panose="020B0604020202020204" pitchFamily="34" charset="0"/>
+              </a:rPr>
+              <a:t>.</a:t>
+            </a:r>
+          </a:p>
+        </p:txBody>
+      </p:sp>
+    </p:spTree>
+    <p:extLst>
+      <p:ext uri="{BB962C8B-B14F-4D97-AF65-F5344CB8AC3E}">
+        <p14:creationId xmlns:p14="http://schemas.microsoft.com/office/powerpoint/2010/main" val="1465937928"/>
+      </p:ext>
+    </p:extLst>
+  </p:cSld>
+  <p:clrMapOvr>
+    <a:masterClrMapping/>
+  </p:clrMapOvr>
+</p:sld>
+</file>
+
+<file path=ppt/slides/slide8.xml><?xml version="1.0" encoding="utf-8"?>
+<p:sld xmlns:a="http://schemas.openxmlformats.org/drawingml/2006/main" xmlns:r="http://schemas.openxmlformats.org/officeDocument/2006/relationships" xmlns:p="http://schemas.openxmlformats.org/presentationml/2006/main">
+  <p:cSld>
+    <p:spTree>
+      <p:nvGrpSpPr>
+        <p:cNvPr id="1" name="">
+          <a:extLst>
+            <a:ext uri="{FF2B5EF4-FFF2-40B4-BE49-F238E27FC236}">
+              <a16:creationId xmlns:a16="http://schemas.microsoft.com/office/drawing/2014/main" id="{F90ACD1F-7576-333E-89F2-342A21B4CAB0}"/>
+            </a:ext>
+          </a:extLst>
+        </p:cNvPr>
+        <p:cNvGrpSpPr/>
+        <p:nvPr/>
+      </p:nvGrpSpPr>
+      <p:grpSpPr>
+        <a:xfrm>
+          <a:off x="0" y="0"/>
+          <a:ext cx="0" cy="0"/>
+          <a:chOff x="0" y="0"/>
+          <a:chExt cx="0" cy="0"/>
+        </a:xfrm>
+      </p:grpSpPr>
+      <p:sp>
+        <p:nvSpPr>
+          <p:cNvPr id="3" name="TextBox 2">
+            <a:extLst>
+              <a:ext uri="{FF2B5EF4-FFF2-40B4-BE49-F238E27FC236}">
+                <a16:creationId xmlns:a16="http://schemas.microsoft.com/office/drawing/2014/main" id="{BBCB5DA4-6905-DA06-8EB7-2BE11C5C02EC}"/>
+              </a:ext>
+            </a:extLst>
+          </p:cNvPr>
+          <p:cNvSpPr txBox="1"/>
+          <p:nvPr/>
+        </p:nvSpPr>
+        <p:spPr>
+          <a:xfrm>
+            <a:off x="217714" y="255046"/>
+            <a:ext cx="11756571" cy="355354"/>
+          </a:xfrm>
+          <a:prstGeom prst="rect">
+            <a:avLst/>
+          </a:prstGeom>
+          <a:noFill/>
+        </p:spPr>
+        <p:txBody>
+          <a:bodyPr wrap="square">
+            <a:spAutoFit/>
+          </a:bodyPr>
+          <a:lstStyle/>
+          <a:p>
+            <a:pPr>
+              <a:lnSpc>
+                <a:spcPct val="150000"/>
+              </a:lnSpc>
+              <a:buNone/>
+            </a:pPr>
+            <a:r>
+              <a:rPr kumimoji="0" lang="en-US" altLang="en-US" sz="1300" b="0" i="0" u="none" strike="noStrike" cap="none" normalizeH="0" baseline="0">
+                <a:ln>
+                  <a:noFill/>
+                </a:ln>
+                <a:solidFill>
+                  <a:schemeClr val="tx1"/>
+                </a:solidFill>
+                <a:effectLst/>
+                <a:latin typeface="Arial" panose="020B0604020202020204" pitchFamily="34" charset="0"/>
+              </a:rPr>
+              <a:t>.</a:t>
+            </a:r>
+          </a:p>
+        </p:txBody>
+      </p:sp>
+    </p:spTree>
+    <p:extLst>
+      <p:ext uri="{BB962C8B-B14F-4D97-AF65-F5344CB8AC3E}">
+        <p14:creationId xmlns:p14="http://schemas.microsoft.com/office/powerpoint/2010/main" val="3341737437"/>
       </p:ext>
     </p:extLst>
   </p:cSld>

</xml_diff>